<commit_message>
Remove temporary lock file and update README with interactive application links
</commit_message>
<xml_diff>
--- a/Semana_3/Semana_3_ISO_IEC_29110.pptx
+++ b/Semana_3/Semana_3_ISO_IEC_29110.pptx
@@ -3464,8 +3464,8 @@
         </p:nvSpPr>
         <p:spPr>
           <a:xfrm>
-            <a:off x="320040" y="4846320"/>
-            <a:ext cx="8503920" cy="201168"/>
+            <a:off x="4343400" y="4663440"/>
+            <a:ext cx="4480560" cy="384048"/>
           </a:xfrm>
           <a:prstGeom prst="rect">
             <a:avLst/>
@@ -3477,13 +3477,13 @@
           <a:bodyPr wrap="square" rtlCol="0" anchor="ctr"/>
           <a:lstStyle/>
           <a:p>
-            <a:pPr marL="0" indent="0">
+            <a:pPr marL="0" indent="0" algn="r">
               <a:buNone/>
             </a:pPr>
             <a:r>
-              <a:rPr lang="en-US" sz="950" i="1" dirty="0">
-                <a:solidFill>
-                  <a:srgbClr val="444444"/>
+              <a:rPr lang="en-US" sz="900" i="1" dirty="0">
+                <a:solidFill>
+                  <a:srgbClr val="333333"/>
                 </a:solidFill>
                 <a:latin typeface="Calibri" pitchFamily="34" charset="0"/>
                 <a:ea typeface="Calibri" pitchFamily="34" charset="-122"/>
@@ -4976,8 +4976,8 @@
         </p:nvSpPr>
         <p:spPr>
           <a:xfrm>
-            <a:off x="320040" y="4828032"/>
-            <a:ext cx="8503920" cy="201168"/>
+            <a:off x="4343400" y="4663440"/>
+            <a:ext cx="4480560" cy="384048"/>
           </a:xfrm>
           <a:prstGeom prst="rect">
             <a:avLst/>
@@ -4989,13 +4989,13 @@
           <a:bodyPr wrap="square" rtlCol="0" anchor="ctr"/>
           <a:lstStyle/>
           <a:p>
-            <a:pPr marL="0" indent="0">
+            <a:pPr marL="0" indent="0" algn="r">
               <a:buNone/>
             </a:pPr>
             <a:r>
-              <a:rPr lang="en-US" sz="1000" i="1" dirty="0">
-                <a:solidFill>
-                  <a:srgbClr val="444444"/>
+              <a:rPr lang="en-US" sz="900" i="1" dirty="0">
+                <a:solidFill>
+                  <a:srgbClr val="333333"/>
                 </a:solidFill>
                 <a:latin typeface="Calibri" pitchFamily="34" charset="0"/>
                 <a:ea typeface="Calibri" pitchFamily="34" charset="-122"/>
@@ -5756,8 +5756,8 @@
           </p:nvPr>
         </p:nvGraphicFramePr>
         <p:xfrm>
-          <a:off x="320040" y="1389888"/>
-          <a:ext cx="8503920" cy="3401570"/>
+          <a:off x="320040" y="1536192"/>
+          <a:ext cx="8503920" cy="2779776"/>
         </p:xfrm>
         <a:graphic>
           <a:graphicData uri="http://schemas.openxmlformats.org/drawingml/2006/table">
@@ -5793,7 +5793,7 @@
                   </a:extLst>
                 </a:gridCol>
               </a:tblGrid>
-              <a:tr h="680314">
+              <a:tr h="292608">
                 <a:tc>
                   <a:txBody>
                     <a:bodyPr/>
@@ -6072,7 +6072,7 @@
                   </a:ext>
                 </a:extLst>
               </a:tr>
-              <a:tr h="680314">
+              <a:tr h="621792">
                 <a:tc>
                   <a:txBody>
                     <a:bodyPr/>
@@ -6351,7 +6351,7 @@
                   </a:ext>
                 </a:extLst>
               </a:tr>
-              <a:tr h="680314">
+              <a:tr h="621792">
                 <a:tc>
                   <a:txBody>
                     <a:bodyPr/>
@@ -6630,7 +6630,7 @@
                   </a:ext>
                 </a:extLst>
               </a:tr>
-              <a:tr h="680314">
+              <a:tr h="621792">
                 <a:tc>
                   <a:txBody>
                     <a:bodyPr/>
@@ -6909,7 +6909,7 @@
                   </a:ext>
                 </a:extLst>
               </a:tr>
-              <a:tr h="680314">
+              <a:tr h="621792">
                 <a:tc>
                   <a:txBody>
                     <a:bodyPr/>
@@ -7200,8 +7200,8 @@
         </p:nvSpPr>
         <p:spPr>
           <a:xfrm>
-            <a:off x="320040" y="4846320"/>
-            <a:ext cx="8503920" cy="201168"/>
+            <a:off x="320040" y="1243584"/>
+            <a:ext cx="8503920" cy="256032"/>
           </a:xfrm>
           <a:prstGeom prst="rect">
             <a:avLst/>

</xml_diff>